<commit_message>
docs: update README and presentation slides with Review 3 architecture and benchmark results
</commit_message>
<xml_diff>
--- a/Review2_Populated.pptx
+++ b/Review2_Populated.pptx
@@ -5,7 +5,7 @@
     <p:sldMasterId id="2147483648" r:id="rId1"/>
   </p:sldMasterIdLst>
   <p:notesMasterIdLst>
-    <p:notesMasterId r:id="rId17"/>
+    <p:notesMasterId r:id="rId11"/>
   </p:notesMasterIdLst>
   <p:sldIdLst>
     <p:sldId id="256" r:id="rId2"/>
@@ -17,12 +17,12 @@
     <p:sldId id="261" r:id="rId8"/>
     <p:sldId id="265" r:id="rId9"/>
     <p:sldId id="266" r:id="rId10"/>
-    <p:sldId id="267" r:id="rId11"/>
-    <p:sldId id="268" r:id="rId12"/>
-    <p:sldId id="269" r:id="rId13"/>
-    <p:sldId id="270" r:id="rId14"/>
-    <p:sldId id="271" r:id="rId15"/>
-    <p:sldId id="272" r:id="rId16"/>
+    <p:sldId id="267" r:id="rId16"/>
+    <p:sldId id="268" r:id="rId17"/>
+    <p:sldId id="269" r:id="rId18"/>
+    <p:sldId id="270" r:id="rId19"/>
+    <p:sldId id="271" r:id="rId20"/>
+    <p:sldId id="272" r:id="rId21"/>
   </p:sldIdLst>
   <p:sldSz cx="12192000" cy="6858000"/>
   <p:notesSz cx="6858000" cy="9144000"/>
@@ -4124,7 +4124,7 @@
 </file>
 
 <file path=ppt/slides/slide10.xml><?xml version="1.0" encoding="utf-8"?>
-<p:sld xmlns:a="http://schemas.openxmlformats.org/drawingml/2006/main" xmlns:r="http://schemas.openxmlformats.org/officeDocument/2006/relationships" xmlns:p="http://schemas.openxmlformats.org/presentationml/2006/main">
+<p:sld xmlns:a="http://schemas.openxmlformats.org/drawingml/2006/main" xmlns:p="http://schemas.openxmlformats.org/presentationml/2006/main" xmlns:r="http://schemas.openxmlformats.org/officeDocument/2006/relationships">
   <p:cSld>
     <p:spTree>
       <p:nvGrpSpPr>
@@ -4132,14 +4132,7 @@
         <p:cNvGrpSpPr/>
         <p:nvPr/>
       </p:nvGrpSpPr>
-      <p:grpSpPr>
-        <a:xfrm>
-          <a:off x="0" y="0"/>
-          <a:ext cx="0" cy="0"/>
-          <a:chOff x="0" y="0"/>
-          <a:chExt cx="0" cy="0"/>
-        </a:xfrm>
-      </p:grpSpPr>
+      <p:grpSpPr/>
       <p:sp>
         <p:nvSpPr>
           <p:cNvPr id="2" name="Title 1"/>
@@ -4179,20 +4172,11 @@
             <p:ph idx="1"/>
           </p:nvPr>
         </p:nvSpPr>
-        <p:spPr>
-          <a:xfrm>
-            <a:off x="838200" y="1825625"/>
-            <a:ext cx="10515600" cy="170323"/>
-          </a:xfrm>
-        </p:spPr>
-        <p:txBody>
-          <a:bodyPr>
-            <a:normAutofit fontScale="25000" lnSpcReduction="20000"/>
-          </a:bodyPr>
-          <a:lstStyle/>
-          <a:p>
-            <a:endParaRPr dirty="0"/>
-          </a:p>
+        <p:spPr/>
+        <p:txBody>
+          <a:bodyPr/>
+          <a:lstStyle/>
+          <a:p/>
         </p:txBody>
       </p:sp>
       <p:sp>
@@ -4309,7 +4293,7 @@
         <p:spPr>
           <a:xfrm>
             <a:off x="841248" y="1508760"/>
-            <a:ext cx="10424160" cy="3450496"/>
+            <a:ext cx="10424160" cy="4572000"/>
           </a:xfrm>
           <a:prstGeom prst="rect">
             <a:avLst/>
@@ -4331,7 +4315,7 @@
               </a:spcAft>
             </a:pPr>
             <a:r>
-              <a:rPr sz="1500" b="1" dirty="0">
+              <a:rPr sz="1500" b="1">
                 <a:solidFill>
                   <a:srgbClr val="004B87"/>
                 </a:solidFill>
@@ -4340,31 +4324,13 @@
               <a:t>Stage 0 — Assay-Method Classifier: </a:t>
             </a:r>
             <a:r>
-              <a:rPr sz="1450" b="0" dirty="0">
+              <a:rPr sz="1450" b="0">
                 <a:solidFill>
                   <a:srgbClr val="1E1E1E"/>
                 </a:solidFill>
                 <a:latin typeface="Arial"/>
               </a:rPr>
-              <a:t>Dynamically inspects methodology headers to determine verification routing (Direct Enzymatic Assay vs. </a:t>
-            </a:r>
-            <a:r>
-              <a:rPr sz="1450" b="0" dirty="0" err="1">
-                <a:solidFill>
-                  <a:srgbClr val="1E1E1E"/>
-                </a:solidFill>
-                <a:latin typeface="Arial"/>
-              </a:rPr>
-              <a:t>Friedewald</a:t>
-            </a:r>
-            <a:r>
-              <a:rPr sz="1450" b="0" dirty="0">
-                <a:solidFill>
-                  <a:srgbClr val="1E1E1E"/>
-                </a:solidFill>
-                <a:latin typeface="Arial"/>
-              </a:rPr>
-              <a:t> Panel).</a:t>
+              <a:t>Dynamically inspects methodology headers to determine verification routing (Direct Enzymatic Assay vs. Calculated Friedewald Panel).</a:t>
             </a:r>
           </a:p>
           <a:p>
@@ -4377,7 +4343,7 @@
               </a:spcAft>
             </a:pPr>
             <a:r>
-              <a:rPr sz="1500" b="1" dirty="0">
+              <a:rPr sz="1500" b="1">
                 <a:solidFill>
                   <a:srgbClr val="004B87"/>
                 </a:solidFill>
@@ -4386,7 +4352,7 @@
               <a:t>Stage 1 — Multimodal Base Extraction: </a:t>
             </a:r>
             <a:r>
-              <a:rPr sz="1450" b="0" dirty="0">
+              <a:rPr sz="1450" b="0">
                 <a:solidFill>
                   <a:srgbClr val="1E1E1E"/>
                 </a:solidFill>
@@ -4405,7 +4371,7 @@
               </a:spcAft>
             </a:pPr>
             <a:r>
-              <a:rPr sz="1500" b="1" dirty="0">
+              <a:rPr sz="1500" b="1">
                 <a:solidFill>
                   <a:srgbClr val="004B87"/>
                 </a:solidFill>
@@ -4414,31 +4380,13 @@
               <a:t>Stage 2 &amp; 2.5 — Invariant Verifier &amp; Fault Isolation: </a:t>
             </a:r>
             <a:r>
-              <a:rPr sz="1450" b="0" dirty="0">
+              <a:rPr sz="1450" b="0">
                 <a:solidFill>
                   <a:srgbClr val="1E1E1E"/>
                 </a:solidFill>
                 <a:latin typeface="Arial"/>
               </a:rPr>
-              <a:t>Deterministically evaluates </a:t>
-            </a:r>
-            <a:r>
-              <a:rPr sz="1450" b="0" dirty="0" err="1">
-                <a:solidFill>
-                  <a:srgbClr val="1E1E1E"/>
-                </a:solidFill>
-                <a:latin typeface="Arial"/>
-              </a:rPr>
-              <a:t>Friedewald</a:t>
-            </a:r>
-            <a:r>
-              <a:rPr sz="1450" b="0" dirty="0">
-                <a:solidFill>
-                  <a:srgbClr val="1E1E1E"/>
-                </a:solidFill>
-                <a:latin typeface="Arial"/>
-              </a:rPr>
-              <a:t> equality (TC = HDL + LDL + TG/5) with physiological bounds; isolates suspect fields via algebraic counterfactual search (k=1 single-field and k=2 combinatorial pairs).</a:t>
+              <a:t>Deterministically evaluates Friedewald equality (TC = HDL + LDL + TG/5) with physiological bounds; isolates suspect fields via algebraic counterfactual search (k=1 single-field and k=2 combinatorial pairs).</a:t>
             </a:r>
           </a:p>
           <a:p>
@@ -4451,7 +4399,7 @@
               </a:spcAft>
             </a:pPr>
             <a:r>
-              <a:rPr sz="1500" b="1" dirty="0">
+              <a:rPr sz="1500" b="1">
                 <a:solidFill>
                   <a:srgbClr val="004B87"/>
                 </a:solidFill>
@@ -4460,7 +4408,7 @@
               <a:t>Stage 3 &amp; 4 — Vision Gate &amp; Micro-Crop Re-Extraction: </a:t>
             </a:r>
             <a:r>
-              <a:rPr sz="1450" b="0" dirty="0">
+              <a:rPr sz="1450" b="0">
                 <a:solidFill>
                   <a:srgbClr val="1E1E1E"/>
                 </a:solidFill>
@@ -4479,7 +4427,7 @@
               </a:spcAft>
             </a:pPr>
             <a:r>
-              <a:rPr sz="1500" b="1" dirty="0">
+              <a:rPr sz="1500" b="1">
                 <a:solidFill>
                   <a:srgbClr val="004B87"/>
                 </a:solidFill>
@@ -4488,7 +4436,7 @@
               <a:t>Stage 5 — Bounded Loop Controller &amp; Audit Logger: </a:t>
             </a:r>
             <a:r>
-              <a:rPr sz="1450" b="0" dirty="0">
+              <a:rPr sz="1450" b="0">
                 <a:solidFill>
                   <a:srgbClr val="1E1E1E"/>
                 </a:solidFill>
@@ -4508,7 +4456,7 @@
 </file>
 
 <file path=ppt/slides/slide11.xml><?xml version="1.0" encoding="utf-8"?>
-<p:sld xmlns:a="http://schemas.openxmlformats.org/drawingml/2006/main" xmlns:r="http://schemas.openxmlformats.org/officeDocument/2006/relationships" xmlns:p="http://schemas.openxmlformats.org/presentationml/2006/main">
+<p:sld xmlns:a="http://schemas.openxmlformats.org/drawingml/2006/main" xmlns:p="http://schemas.openxmlformats.org/presentationml/2006/main" xmlns:r="http://schemas.openxmlformats.org/officeDocument/2006/relationships">
   <p:cSld>
     <p:spTree>
       <p:nvGrpSpPr>
@@ -4516,14 +4464,7 @@
         <p:cNvGrpSpPr/>
         <p:nvPr/>
       </p:nvGrpSpPr>
-      <p:grpSpPr>
-        <a:xfrm>
-          <a:off x="0" y="0"/>
-          <a:ext cx="0" cy="0"/>
-          <a:chOff x="0" y="0"/>
-          <a:chExt cx="0" cy="0"/>
-        </a:xfrm>
-      </p:grpSpPr>
+      <p:grpSpPr/>
       <p:sp>
         <p:nvSpPr>
           <p:cNvPr id="2" name="Title 1"/>
@@ -4563,20 +4504,11 @@
             <p:ph idx="1"/>
           </p:nvPr>
         </p:nvSpPr>
-        <p:spPr>
-          <a:xfrm flipV="1">
-            <a:off x="838200" y="1234440"/>
-            <a:ext cx="10515600" cy="73250"/>
-          </a:xfrm>
-        </p:spPr>
-        <p:txBody>
-          <a:bodyPr>
-            <a:normAutofit fontScale="25000" lnSpcReduction="20000"/>
-          </a:bodyPr>
-          <a:lstStyle/>
-          <a:p>
-            <a:endParaRPr/>
-          </a:p>
+        <p:spPr/>
+        <p:txBody>
+          <a:bodyPr/>
+          <a:lstStyle/>
+          <a:p/>
         </p:txBody>
       </p:sp>
       <p:sp>
@@ -4715,7 +4647,7 @@
               </a:spcAft>
             </a:pPr>
             <a:r>
-              <a:rPr sz="1500" b="1" dirty="0">
+              <a:rPr sz="1500" b="1">
                 <a:solidFill>
                   <a:srgbClr val="004B87"/>
                 </a:solidFill>
@@ -4724,7 +4656,7 @@
               <a:t>Dynamic Methodology Routing: </a:t>
             </a:r>
             <a:r>
-              <a:rPr sz="1450" b="0" dirty="0">
+              <a:rPr sz="1450" b="0">
                 <a:solidFill>
                   <a:srgbClr val="1E1E1E"/>
                 </a:solidFill>
@@ -4743,7 +4675,7 @@
               </a:spcAft>
             </a:pPr>
             <a:r>
-              <a:rPr sz="1500" b="1" dirty="0">
+              <a:rPr sz="1500" b="1">
                 <a:solidFill>
                   <a:srgbClr val="004B87"/>
                 </a:solidFill>
@@ -4752,31 +4684,13 @@
               <a:t>Deterministic Invariant Verification: </a:t>
             </a:r>
             <a:r>
-              <a:rPr sz="1450" b="0" dirty="0">
+              <a:rPr sz="1450" b="0">
                 <a:solidFill>
                   <a:srgbClr val="1E1E1E"/>
                 </a:solidFill>
                 <a:latin typeface="Arial"/>
               </a:rPr>
-              <a:t>The system must strictly verify extraction integrity using domain-standard physiological laws (the </a:t>
-            </a:r>
-            <a:r>
-              <a:rPr sz="1450" b="0" dirty="0" err="1">
-                <a:solidFill>
-                  <a:srgbClr val="1E1E1E"/>
-                </a:solidFill>
-                <a:latin typeface="Arial"/>
-              </a:rPr>
-              <a:t>Friedewald</a:t>
-            </a:r>
-            <a:r>
-              <a:rPr sz="1450" b="0" dirty="0">
-                <a:solidFill>
-                  <a:srgbClr val="1E1E1E"/>
-                </a:solidFill>
-                <a:latin typeface="Arial"/>
-              </a:rPr>
-              <a:t> identity) within a strict numerical tolerance window (+/-10%).</a:t>
+              <a:t>The system must strictly verify extraction integrity using domain-standard physiological laws (the Friedewald identity) within a strict numerical tolerance window (+/-10%).</a:t>
             </a:r>
           </a:p>
           <a:p>
@@ -4789,7 +4703,7 @@
               </a:spcAft>
             </a:pPr>
             <a:r>
-              <a:rPr sz="1500" b="1" dirty="0">
+              <a:rPr sz="1500" b="1">
                 <a:solidFill>
                   <a:srgbClr val="004B87"/>
                 </a:solidFill>
@@ -4798,31 +4712,13 @@
               <a:t>Autonomous Multi-Order Fault Isolation: </a:t>
             </a:r>
             <a:r>
-              <a:rPr sz="1450" b="0" dirty="0">
+              <a:rPr sz="1450" b="0">
                 <a:solidFill>
                   <a:srgbClr val="1E1E1E"/>
                 </a:solidFill>
                 <a:latin typeface="Arial"/>
               </a:rPr>
-              <a:t>The system must systematically isolate single-field (k=1) and double-field (k=2) transcription corruptions using algebraic counterfactual search, </a:t>
-            </a:r>
-            <a:r>
-              <a:rPr sz="1450" b="0" dirty="0" err="1">
-                <a:solidFill>
-                  <a:srgbClr val="1E1E1E"/>
-                </a:solidFill>
-                <a:latin typeface="Arial"/>
-              </a:rPr>
-              <a:t>Levenshtein</a:t>
-            </a:r>
-            <a:r>
-              <a:rPr sz="1450" b="0" dirty="0">
-                <a:solidFill>
-                  <a:srgbClr val="1E1E1E"/>
-                </a:solidFill>
-                <a:latin typeface="Arial"/>
-              </a:rPr>
-              <a:t> distance, and confidence scoring.</a:t>
+              <a:t>The system must systematically isolate single-field (k=1) and double-field (k=2) transcription corruptions using algebraic counterfactual search, Levenshtein distance, and confidence scoring.</a:t>
             </a:r>
           </a:p>
           <a:p>
@@ -4835,7 +4731,7 @@
               </a:spcAft>
             </a:pPr>
             <a:r>
-              <a:rPr sz="1500" b="1" dirty="0">
+              <a:rPr sz="1500" b="1">
                 <a:solidFill>
                   <a:srgbClr val="004B87"/>
                 </a:solidFill>
@@ -4844,7 +4740,7 @@
               <a:t>Zero-Harm Clinical Safety Bound: </a:t>
             </a:r>
             <a:r>
-              <a:rPr sz="1450" b="0" dirty="0">
+              <a:rPr sz="1450" b="0">
                 <a:solidFill>
                   <a:srgbClr val="1E1E1E"/>
                 </a:solidFill>
@@ -4863,7 +4759,7 @@
               </a:spcAft>
             </a:pPr>
             <a:r>
-              <a:rPr sz="1500" b="1" dirty="0">
+              <a:rPr sz="1500" b="1">
                 <a:solidFill>
                   <a:srgbClr val="004B87"/>
                 </a:solidFill>
@@ -4872,31 +4768,13 @@
               <a:t>Complete Traceability &amp; Bounded Abstention: </a:t>
             </a:r>
             <a:r>
-              <a:rPr sz="1450" b="0" dirty="0">
+              <a:rPr sz="1450" b="0">
                 <a:solidFill>
                   <a:srgbClr val="1E1E1E"/>
                 </a:solidFill>
                 <a:latin typeface="Arial"/>
               </a:rPr>
-              <a:t>The system must log every internal hypothesis, residual score, and state mutation, safely escalating unresolvable anomalies (K &gt; </a:t>
-            </a:r>
-            <a:r>
-              <a:rPr sz="1450" b="0" dirty="0" err="1">
-                <a:solidFill>
-                  <a:srgbClr val="1E1E1E"/>
-                </a:solidFill>
-                <a:latin typeface="Arial"/>
-              </a:rPr>
-              <a:t>max_attempts</a:t>
-            </a:r>
-            <a:r>
-              <a:rPr sz="1450" b="0" dirty="0">
-                <a:solidFill>
-                  <a:srgbClr val="1E1E1E"/>
-                </a:solidFill>
-                <a:latin typeface="Arial"/>
-              </a:rPr>
-              <a:t>) to human pathologist review.</a:t>
+              <a:t>The system must log every internal hypothesis, residual score, and state mutation, safely escalating unresolvable anomalies (K &gt; max_attempts) to human pathologist review.</a:t>
             </a:r>
           </a:p>
         </p:txBody>
@@ -4910,7 +4788,7 @@
 </file>
 
 <file path=ppt/slides/slide12.xml><?xml version="1.0" encoding="utf-8"?>
-<p:sld xmlns:a="http://schemas.openxmlformats.org/drawingml/2006/main" xmlns:r="http://schemas.openxmlformats.org/officeDocument/2006/relationships" xmlns:p="http://schemas.openxmlformats.org/presentationml/2006/main">
+<p:sld xmlns:a="http://schemas.openxmlformats.org/drawingml/2006/main" xmlns:p="http://schemas.openxmlformats.org/presentationml/2006/main" xmlns:r="http://schemas.openxmlformats.org/officeDocument/2006/relationships">
   <p:cSld>
     <p:spTree>
       <p:nvGrpSpPr>
@@ -4918,14 +4796,7 @@
         <p:cNvGrpSpPr/>
         <p:nvPr/>
       </p:nvGrpSpPr>
-      <p:grpSpPr>
-        <a:xfrm>
-          <a:off x="0" y="0"/>
-          <a:ext cx="0" cy="0"/>
-          <a:chOff x="0" y="0"/>
-          <a:chExt cx="0" cy="0"/>
-        </a:xfrm>
-      </p:grpSpPr>
+      <p:grpSpPr/>
       <p:sp>
         <p:nvSpPr>
           <p:cNvPr id="2" name="Title 1"/>
@@ -4969,9 +4840,7 @@
         <p:txBody>
           <a:bodyPr/>
           <a:lstStyle/>
-          <a:p>
-            <a:endParaRPr/>
-          </a:p>
+          <a:p/>
         </p:txBody>
       </p:sp>
       <p:sp>
@@ -5110,7 +4979,7 @@
               </a:spcAft>
             </a:pPr>
             <a:r>
-              <a:rPr sz="1500" b="1" dirty="0">
+              <a:rPr sz="1500" b="1">
                 <a:solidFill>
                   <a:srgbClr val="004B87"/>
                 </a:solidFill>
@@ -5119,31 +4988,13 @@
               <a:t>src/stage0_classifier.py (Assay Classifier): </a:t>
             </a:r>
             <a:r>
-              <a:rPr sz="1450" b="0" dirty="0">
+              <a:rPr sz="1450" b="0">
                 <a:solidFill>
                   <a:srgbClr val="1E1E1E"/>
                 </a:solidFill>
                 <a:latin typeface="Arial"/>
               </a:rPr>
-              <a:t>Implements </a:t>
-            </a:r>
-            <a:r>
-              <a:rPr sz="1450" b="0" dirty="0" err="1">
-                <a:solidFill>
-                  <a:srgbClr val="1E1E1E"/>
-                </a:solidFill>
-                <a:latin typeface="Arial"/>
-              </a:rPr>
-              <a:t>AssayClassifier</a:t>
-            </a:r>
-            <a:r>
-              <a:rPr sz="1450" b="0" dirty="0">
-                <a:solidFill>
-                  <a:srgbClr val="1E1E1E"/>
-                </a:solidFill>
-                <a:latin typeface="Arial"/>
-              </a:rPr>
-              <a:t> with regex and heuristic pattern matching to route between DIRECT_MEASURED and FRIEDEWALD paths.</a:t>
+              <a:t>Implements AssayClassifier with regex and heuristic pattern matching to route between DIRECT_MEASURED and FRIEDEWALD paths.</a:t>
             </a:r>
           </a:p>
           <a:p>
@@ -5156,7 +5007,7 @@
               </a:spcAft>
             </a:pPr>
             <a:r>
-              <a:rPr sz="1500" b="1" dirty="0">
+              <a:rPr sz="1500" b="1">
                 <a:solidFill>
                   <a:srgbClr val="004B87"/>
                 </a:solidFill>
@@ -5165,7 +5016,7 @@
               <a:t>src/stage1_extract.py (Document State Extractor): </a:t>
             </a:r>
             <a:r>
-              <a:rPr sz="1450" b="0" dirty="0">
+              <a:rPr sz="1450" b="0">
                 <a:solidFill>
                   <a:srgbClr val="1E1E1E"/>
                 </a:solidFill>
@@ -5184,7 +5035,7 @@
               </a:spcAft>
             </a:pPr>
             <a:r>
-              <a:rPr sz="1500" b="1" dirty="0">
+              <a:rPr sz="1500" b="1">
                 <a:solidFill>
                   <a:srgbClr val="004B87"/>
                 </a:solidFill>
@@ -5193,31 +5044,13 @@
               <a:t>src/stage2_constraints.py (Constraint Engine): </a:t>
             </a:r>
             <a:r>
-              <a:rPr sz="1450" b="0" dirty="0">
+              <a:rPr sz="1450" b="0">
                 <a:solidFill>
                   <a:srgbClr val="1E1E1E"/>
                 </a:solidFill>
                 <a:latin typeface="Arial"/>
               </a:rPr>
-              <a:t>Enforces physiological bounds, canonical unit normalization (mmol/L &lt;-&gt; mg/dL), and </a:t>
-            </a:r>
-            <a:r>
-              <a:rPr sz="1450" b="0" dirty="0" err="1">
-                <a:solidFill>
-                  <a:srgbClr val="1E1E1E"/>
-                </a:solidFill>
-                <a:latin typeface="Arial"/>
-              </a:rPr>
-              <a:t>Friedewald</a:t>
-            </a:r>
-            <a:r>
-              <a:rPr sz="1450" b="0" dirty="0">
-                <a:solidFill>
-                  <a:srgbClr val="1E1E1E"/>
-                </a:solidFill>
-                <a:latin typeface="Arial"/>
-              </a:rPr>
-              <a:t> invariant residual calculation.</a:t>
+              <a:t>Enforces physiological bounds, canonical unit normalization (mmol/L &lt;-&gt; mg/dL), and Friedewald invariant residual calculation.</a:t>
             </a:r>
           </a:p>
           <a:p>
@@ -5230,7 +5063,7 @@
               </a:spcAft>
             </a:pPr>
             <a:r>
-              <a:rPr sz="1500" b="1" dirty="0">
+              <a:rPr sz="1500" b="1">
                 <a:solidFill>
                   <a:srgbClr val="004B87"/>
                 </a:solidFill>
@@ -5239,7 +5072,7 @@
               <a:t>src/stage2_isolation.py (Hierarchical Isolation Engine): </a:t>
             </a:r>
             <a:r>
-              <a:rPr sz="1450" b="0" dirty="0">
+              <a:rPr sz="1450" b="0">
                 <a:solidFill>
                   <a:srgbClr val="1E1E1E"/>
                 </a:solidFill>
@@ -5258,7 +5091,7 @@
               </a:spcAft>
             </a:pPr>
             <a:r>
-              <a:rPr sz="1500" b="1" dirty="0">
+              <a:rPr sz="1500" b="1">
                 <a:solidFill>
                   <a:srgbClr val="004B87"/>
                 </a:solidFill>
@@ -5267,7 +5100,7 @@
               <a:t>src/pipeline.py (Closed-Loop Orchestrator): </a:t>
             </a:r>
             <a:r>
-              <a:rPr sz="1450" b="0" dirty="0">
+              <a:rPr sz="1450" b="0">
                 <a:solidFill>
                   <a:srgbClr val="1E1E1E"/>
                 </a:solidFill>
@@ -5286,7 +5119,7 @@
               </a:spcAft>
             </a:pPr>
             <a:r>
-              <a:rPr sz="1500" b="1" dirty="0">
+              <a:rPr sz="1500" b="1">
                 <a:solidFill>
                   <a:srgbClr val="004B87"/>
                 </a:solidFill>
@@ -5295,7 +5128,7 @@
               <a:t>evals/run_ablations.py &amp; evals/metrics.py (Benchmark Harness): </a:t>
             </a:r>
             <a:r>
-              <a:rPr sz="1450" b="0" dirty="0">
+              <a:rPr sz="1450" b="0">
                 <a:solidFill>
                   <a:srgbClr val="1E1E1E"/>
                 </a:solidFill>
@@ -5315,7 +5148,7 @@
 </file>
 
 <file path=ppt/slides/slide13.xml><?xml version="1.0" encoding="utf-8"?>
-<p:sld xmlns:a="http://schemas.openxmlformats.org/drawingml/2006/main" xmlns:r="http://schemas.openxmlformats.org/officeDocument/2006/relationships" xmlns:p="http://schemas.openxmlformats.org/presentationml/2006/main">
+<p:sld xmlns:a="http://schemas.openxmlformats.org/drawingml/2006/main" xmlns:p="http://schemas.openxmlformats.org/presentationml/2006/main" xmlns:r="http://schemas.openxmlformats.org/officeDocument/2006/relationships">
   <p:cSld>
     <p:spTree>
       <p:nvGrpSpPr>
@@ -5323,14 +5156,7 @@
         <p:cNvGrpSpPr/>
         <p:nvPr/>
       </p:nvGrpSpPr>
-      <p:grpSpPr>
-        <a:xfrm>
-          <a:off x="0" y="0"/>
-          <a:ext cx="0" cy="0"/>
-          <a:chOff x="0" y="0"/>
-          <a:chExt cx="0" cy="0"/>
-        </a:xfrm>
-      </p:grpSpPr>
+      <p:grpSpPr/>
       <p:sp>
         <p:nvSpPr>
           <p:cNvPr id="2" name="Title 1"/>
@@ -5374,9 +5200,7 @@
         <p:txBody>
           <a:bodyPr/>
           <a:lstStyle/>
-          <a:p>
-            <a:endParaRPr/>
-          </a:p>
+          <a:p/>
         </p:txBody>
       </p:sp>
       <p:sp>
@@ -5720,7 +5544,7 @@
         <p:spPr>
           <a:xfrm>
             <a:off x="6720840" y="1600200"/>
-            <a:ext cx="4480560" cy="2688336"/>
+            <a:ext cx="4480560" cy="2588768"/>
           </a:xfrm>
           <a:prstGeom prst="rect">
             <a:avLst/>
@@ -5755,7 +5579,7 @@
               </a:lnSpc>
             </a:pPr>
             <a:r>
-              <a:rPr sz="1300" b="1">
+              <a:rPr b="1" sz="1300">
                 <a:solidFill>
                   <a:srgbClr val="004B87"/>
                 </a:solidFill>
@@ -5783,7 +5607,7 @@
 </file>
 
 <file path=ppt/slides/slide14.xml><?xml version="1.0" encoding="utf-8"?>
-<p:sld xmlns:a="http://schemas.openxmlformats.org/drawingml/2006/main" xmlns:r="http://schemas.openxmlformats.org/officeDocument/2006/relationships" xmlns:p="http://schemas.openxmlformats.org/presentationml/2006/main">
+<p:sld xmlns:a="http://schemas.openxmlformats.org/drawingml/2006/main" xmlns:p="http://schemas.openxmlformats.org/presentationml/2006/main" xmlns:r="http://schemas.openxmlformats.org/officeDocument/2006/relationships">
   <p:cSld>
     <p:spTree>
       <p:nvGrpSpPr>
@@ -5791,14 +5615,7 @@
         <p:cNvGrpSpPr/>
         <p:nvPr/>
       </p:nvGrpSpPr>
-      <p:grpSpPr>
-        <a:xfrm>
-          <a:off x="0" y="0"/>
-          <a:ext cx="0" cy="0"/>
-          <a:chOff x="0" y="0"/>
-          <a:chExt cx="0" cy="0"/>
-        </a:xfrm>
-      </p:grpSpPr>
+      <p:grpSpPr/>
       <p:sp>
         <p:nvSpPr>
           <p:cNvPr id="2" name="Title 1"/>
@@ -5842,9 +5659,7 @@
         <p:txBody>
           <a:bodyPr/>
           <a:lstStyle/>
-          <a:p>
-            <a:endParaRPr/>
-          </a:p>
+          <a:p/>
         </p:txBody>
       </p:sp>
       <p:sp>
@@ -6180,7 +5995,7 @@
 </file>
 
 <file path=ppt/slides/slide15.xml><?xml version="1.0" encoding="utf-8"?>
-<p:sld xmlns:a="http://schemas.openxmlformats.org/drawingml/2006/main" xmlns:r="http://schemas.openxmlformats.org/officeDocument/2006/relationships" xmlns:p="http://schemas.openxmlformats.org/presentationml/2006/main">
+<p:sld xmlns:a="http://schemas.openxmlformats.org/drawingml/2006/main" xmlns:p="http://schemas.openxmlformats.org/presentationml/2006/main" xmlns:r="http://schemas.openxmlformats.org/officeDocument/2006/relationships">
   <p:cSld>
     <p:spTree>
       <p:nvGrpSpPr>
@@ -6188,14 +6003,7 @@
         <p:cNvGrpSpPr/>
         <p:nvPr/>
       </p:nvGrpSpPr>
-      <p:grpSpPr>
-        <a:xfrm>
-          <a:off x="0" y="0"/>
-          <a:ext cx="0" cy="0"/>
-          <a:chOff x="0" y="0"/>
-          <a:chExt cx="0" cy="0"/>
-        </a:xfrm>
-      </p:grpSpPr>
+      <p:grpSpPr/>
       <p:sp>
         <p:nvSpPr>
           <p:cNvPr id="2" name="Title 1"/>
@@ -6239,9 +6047,7 @@
         <p:txBody>
           <a:bodyPr/>
           <a:lstStyle/>
-          <a:p>
-            <a:endParaRPr/>
-          </a:p>
+          <a:p/>
         </p:txBody>
       </p:sp>
       <p:sp>
@@ -8547,8 +8353,8 @@
           <a:chExt cx="0" cy="0"/>
         </a:xfrm>
       </p:grpSpPr>
-      <mc:AlternateContent xmlns:mc="http://schemas.openxmlformats.org/markup-compatibility/2006" xmlns:a14="http://schemas.microsoft.com/office/drawing/2010/main">
-        <mc:Choice Requires="a14">
+      <mc:AlternateContent xmlns:mc="http://schemas.openxmlformats.org/markup-compatibility/2006">
+        <mc:Choice xmlns:a14="http://schemas.microsoft.com/office/drawing/2010/main" Requires="a14">
           <p:sp>
             <p:nvSpPr>
               <p:cNvPr id="3" name="Content Placeholder 2">
@@ -8819,7 +8625,7 @@
             </p:txBody>
           </p:sp>
         </mc:Choice>
-        <mc:Fallback xmlns="">
+        <mc:Fallback>
           <p:sp>
             <p:nvSpPr>
               <p:cNvPr id="3" name="Content Placeholder 2">

</xml_diff>